<commit_message>
Rapikan materi notebook dan perjelas visualisasi untuk pemula
</commit_message>
<xml_diff>
--- a/slide/01_pengantar_workshop.pptx
+++ b/slide/01_pengantar_workshop.pptx
@@ -519,7 +519,7 @@
           <a:lstStyle/>
           <a:p>
             <a:r>
-              <a:t>Buka dengan tujuan praktis: peserta keluar dari ruangan bisa menjalankan analisis sendiri. Sebutkan bahwa semua kode sudah diuji dan data tersedia lokal, jadi tidak ada kejutan teknis.</a:t>
+              <a:t>Buka dengan tujuan praktis: peserta keluar dari ruangan bisa menjalankan analisis sendiri. Sebutkan bahwa semua kode sudah diuji dan CSV dibaca dari GitHub dengan koneksi internet.</a:t>
             </a:r>
           </a:p>
         </p:txBody>
@@ -799,7 +799,7 @@
           <a:lstStyle/>
           <a:p>
             <a:r>
-              <a:t>Ini slide penutup yang kuat: setelah dua hari memakai data simulasi, peserta melihat hasil yang sama dengan gaya buku teks pada data asli. Tekankan bahwa semua data sudah tersedia lokal, dan jalur BPS di panduan/04_referensi.md membuka pintu untuk data yang lebih baru.</a:t>
+              <a:t>Ini slide penutup yang kuat: setelah dua hari memakai data simulasi, peserta melihat hasil yang sama dengan gaya buku teks pada data asli. Tekankan bahwa CSV dibaca dari salinan GitHub, dan jalur BPS di pengajar/README.md#sumber membuka pintu untuk data yang lebih baru.</a:t>
             </a:r>
           </a:p>
         </p:txBody>
@@ -1499,7 +1499,7 @@
           <a:lstStyle/>
           <a:p>
             <a:r>
-              <a:t>Lakukan ini bersama-sama di awal. Minta satu peserta berbagi layar untuk memastikan langkahnya sama. Kesalahan paling umum di workshop adalah data belum diunggah.</a:t>
+              <a:t>Lakukan ini bersama-sama di awal. Minta satu peserta berbagi layar untuk memastikan langkahnya sama. Kesalahan paling umum di workshop adalah sel sebelumnya belum dijalankan.</a:t>
             </a:r>
           </a:p>
         </p:txBody>
@@ -6130,7 +6130,7 @@
                 </a:solidFill>
                 <a:latin typeface="Arial"/>
               </a:rPr>
-              <a:t>Referensi: panduan/04_referensi.md; alat: alat_bantu/unduh_data_indonesia.py.</a:t>
+              <a:t>Referensi: pengajar/README.md#sumber; alat: alat_bantu/unduh_data_indonesia.py.</a:t>
             </a:r>
           </a:p>
         </p:txBody>
@@ -7748,7 +7748,7 @@
                 </a:solidFill>
                 <a:latin typeface="Arial"/>
               </a:rPr>
-              <a:t>Folder data/ kosong di Colab</a:t>
+              <a:t>CSV belum terbaca dari GitHub</a:t>
             </a:r>
           </a:p>
           <a:p>
@@ -7977,7 +7977,7 @@
                 </a:solidFill>
                 <a:latin typeface="Arial"/>
               </a:rPr>
-              <a:t>Unggah data_tutorial.zip, jalankan sel pertama</a:t>
+              <a:t>Periksa internet, lalu jalankan sel alamat data</a:t>
             </a:r>
           </a:p>
           <a:p>
@@ -8034,7 +8034,7 @@
                 </a:solidFill>
                 <a:latin typeface="Arial"/>
               </a:rPr>
-              <a:t>Unggah ulang data, simpan salinan notebook ke Drive</a:t>
+              <a:t>Jalankan ulang dari atas; simpan notebook ke Drive</a:t>
             </a:r>
           </a:p>
         </p:txBody>
@@ -8243,7 +8243,7 @@
                 </a:solidFill>
                 <a:latin typeface="Arial"/>
               </a:rPr>
-              <a:t>Semua kode sederhana, semua data lokal, semua sudah diuji berjalan.</a:t>
+              <a:t>Jalankan kode berurutan, baca grafik, lalu jelaskan hasilnya.</a:t>
             </a:r>
           </a:p>
         </p:txBody>
@@ -8557,7 +8557,7 @@
                 </a:solidFill>
                 <a:latin typeface="Arial"/>
               </a:rPr>
-              <a:t>Semua data tersedia lokal di folder data/, tanpa mengambil dari internet.</a:t>
+              <a:t>Notebook membaca CSV langsung dari GitHub; gunakan koneksi internet.</a:t>
             </a:r>
           </a:p>
           <a:p>
@@ -10553,7 +10553,7 @@
                 </a:solidFill>
                 <a:latin typeface="Arial"/>
               </a:rPr>
-              <a:t>Unduh paket workshop, lalu unggah data_tutorial.zip ke panel Files di Colab.</a:t>
+              <a:t>Buka notebook .ipynb dari tautan pada README utama.</a:t>
             </a:r>
           </a:p>
           <a:p>
@@ -10572,7 +10572,7 @@
                 </a:solidFill>
                 <a:latin typeface="Arial"/>
               </a:rPr>
-              <a:t>Jalankan sel pertama di notebook: zip diekstrak otomatis ke folder data/.</a:t>
+              <a:t>Jalankan sel alamat data, lalu lanjutkan sel secara berurutan.</a:t>
             </a:r>
           </a:p>
           <a:p>
@@ -10591,7 +10591,7 @@
                 </a:solidFill>
                 <a:latin typeface="Arial"/>
               </a:rPr>
-              <a:t>Semua notebook membaca data lokal, contoh: pd.read_csv("data/uts_2.csv").</a:t>
+              <a:t>Baca tabel Kenali data dan lima baris contoh sebelum memasang model.</a:t>
             </a:r>
           </a:p>
           <a:p>
@@ -10610,7 +10610,7 @@
                 </a:solidFill>
                 <a:latin typeface="Arial"/>
               </a:rPr>
-              <a:t>Kalau folder data/ kosong, sel pertama akan mengingatkan untuk mengunggah zip.</a:t>
+              <a:t>CSV dan ZIP tidak perlu diunggah ke Google Colab.</a:t>
             </a:r>
           </a:p>
         </p:txBody>

</xml_diff>

<commit_message>
Fokuskan Sesi 00 pada EDA dan perjelas visual pembelajaran
</commit_message>
<xml_diff>
--- a/slide/01_pengantar_workshop.pptx
+++ b/slide/01_pengantar_workshop.pptx
@@ -8940,7 +8940,7 @@
                 </a:solidFill>
                 <a:latin typeface="Arial"/>
               </a:rPr>
-              <a:t>00. Persiapan Colab dan padanan EViews</a:t>
+              <a:t>00. Persiapan Colab dan eksplorasi data</a:t>
             </a:r>
           </a:p>
           <a:p>
@@ -9226,7 +9226,7 @@
                 </a:solidFill>
                 <a:latin typeface="Arial"/>
               </a:rPr>
-              <a:t>Lab 0. Mulai dari nol</a:t>
+              <a:t>Lab 0. Membaca dan mengeksplorasi data</a:t>
             </a:r>
           </a:p>
           <a:p>

</xml_diff>

<commit_message>
Rapikan alur tutorial, nama data, dan panduan fungsi untuk pemula
</commit_message>
<xml_diff>
--- a/slide/01_pengantar_workshop.pptx
+++ b/slide/01_pengantar_workshop.pptx
@@ -6737,7 +6737,7 @@
                 </a:solidFill>
                 <a:latin typeface="Courier New"/>
               </a:rPr>
-              <a:t>saham = pd.read_csv("data/uts_2.csv")</a:t>
+              <a:t>saham = pd.read_csv("data/harga_saham_perusahaan.csv")</a:t>
             </a:r>
           </a:p>
           <a:p>
@@ -7209,7 +7209,7 @@
                 </a:solidFill>
                 <a:latin typeface="Courier New"/>
               </a:rPr>
-              <a:t>data = pd.read_csv("data/logit_probit_2.csv")</a:t>
+              <a:t>data = pd.read_csv("data/kelulusan_mahasiswa.csv")</a:t>
             </a:r>
           </a:p>
           <a:p>

</xml_diff>